<commit_message>
fix(thesis): sharp diagrams in presentation, no downscale to box
The "right-size to box PPI" logic shrank Mermaid diagrams to their small
on-slide box (DB schema down to 971px wide), so they looked blurry when
zoomed. Diagrams now keep full resolution (capped at 4000px longest side);
Mermaid sources re-rendered at scale 6 -> figures/presentation/diagram-*.png.
DB schema is now 2398px wide (741 PPI on slide); screenshots stay 300 PPI.

Co-Authored-By: Claude Opus 4.7 (1M context) <noreply@anthropic.com>
</commit_message>
<xml_diff>
--- a/thesis/presentation.pptx
+++ b/thesis/presentation.pptx
@@ -10041,7 +10041,7 @@
             </a:lvl9pPr>
           </a:lstStyle>
           <a:p>
-            <a:fld id="{E71E3CA0-DCCA-4614-AA41-90CDCF33FFEC}" type="slidenum">
+            <a:fld id="{C664F19B-AAA8-4B0F-AB51-3466998EFDA6}" type="slidenum">
               <a:t>9</a:t>
             </a:fld>
           </a:p>
@@ -10208,7 +10208,7 @@
             </a:lvl9pPr>
           </a:lstStyle>
           <a:p>
-            <a:fld id="{BC123477-0FDC-47A9-B8E6-9094FD87AE30}" type="slidenum">
+            <a:fld id="{627D5FA5-D562-4D3D-B0C1-10EE516175F4}" type="slidenum">
               <a:t>10</a:t>
             </a:fld>
           </a:p>
@@ -10375,7 +10375,7 @@
             </a:lvl9pPr>
           </a:lstStyle>
           <a:p>
-            <a:fld id="{4A5AD04A-2CFC-465F-A78E-FA1DA451E62C}" type="slidenum">
+            <a:fld id="{3530FC3A-5454-45FC-817A-55BA54E4C974}" type="slidenum">
               <a:t>11</a:t>
             </a:fld>
           </a:p>
@@ -10542,7 +10542,7 @@
             </a:lvl9pPr>
           </a:lstStyle>
           <a:p>
-            <a:fld id="{2013976B-156C-4B03-8363-E7059B405681}" type="slidenum">
+            <a:fld id="{58F868B0-A178-4A3B-BBAA-50E7909ADAE9}" type="slidenum">
               <a:t>12</a:t>
             </a:fld>
           </a:p>
@@ -10743,7 +10743,7 @@
             </a:lvl9pPr>
           </a:lstStyle>
           <a:p>
-            <a:fld id="{29133431-0B20-44EB-860D-FF8A8CEABB20}" type="slidenum">
+            <a:fld id="{23DE5063-2074-4597-9FD6-D081839376EA}" type="slidenum">
               <a:t>13</a:t>
             </a:fld>
           </a:p>
@@ -10994,7 +10994,7 @@
             </a:lvl9pPr>
           </a:lstStyle>
           <a:p>
-            <a:fld id="{710E0058-7D56-4D1D-ACAA-B62F24C9C441}" type="slidenum">
+            <a:fld id="{62DFF792-164E-4D60-B6ED-4475E6D66A99}" type="slidenum">
               <a:t>1</a:t>
             </a:fld>
           </a:p>
@@ -11165,7 +11165,7 @@
             </a:lvl9pPr>
           </a:lstStyle>
           <a:p>
-            <a:fld id="{9139D5FB-A422-45C6-BE58-E136601782EB}" type="slidenum">
+            <a:fld id="{E9CD3E03-0A1B-4E8D-8F3D-482F26F1C959}" type="slidenum">
               <a:t>2</a:t>
             </a:fld>
           </a:p>
@@ -11913,7 +11913,7 @@
             </a:lvl9pPr>
           </a:lstStyle>
           <a:p>
-            <a:fld id="{0E06486E-22D1-4472-9837-139818FFB6A4}" type="slidenum">
+            <a:fld id="{F1382105-3A9A-4626-8CD3-2DF9A4B7B7F7}" type="slidenum">
               <a:t>3</a:t>
             </a:fld>
           </a:p>
@@ -11960,7 +11960,7 @@
       </p:sp>
       <p:pic>
         <p:nvPicPr>
-          <p:cNvPr id="3" name="Picture 2" descr="1-4.png"/>
+          <p:cNvPr id="3" name="Picture 2" descr="diagram-usecase.png"/>
           <p:cNvPicPr>
             <a:picLocks noChangeAspect="1"/>
           </p:cNvPicPr>
@@ -12080,7 +12080,7 @@
             </a:lvl9pPr>
           </a:lstStyle>
           <a:p>
-            <a:fld id="{4720CEAB-357C-4971-9A5A-0EAF2B3EAD1B}" type="slidenum">
+            <a:fld id="{6EB323E4-730B-494B-BC72-55EC0C294DBD}" type="slidenum">
               <a:t>4</a:t>
             </a:fld>
           </a:p>
@@ -12127,7 +12127,7 @@
       </p:sp>
       <p:pic>
         <p:nvPicPr>
-          <p:cNvPr id="3" name="Picture 2" descr="4-1.png"/>
+          <p:cNvPr id="3" name="Picture 2" descr="diagram-arch.png"/>
           <p:cNvPicPr>
             <a:picLocks noChangeAspect="1"/>
           </p:cNvPicPr>
@@ -12247,7 +12247,7 @@
             </a:lvl9pPr>
           </a:lstStyle>
           <a:p>
-            <a:fld id="{1C20D340-5F0C-4B92-9355-EB48FD930468}" type="slidenum">
+            <a:fld id="{38CC5E90-4CB0-431E-AFDE-2FED6171BE78}" type="slidenum">
               <a:t>5</a:t>
             </a:fld>
           </a:p>
@@ -12294,7 +12294,7 @@
       </p:sp>
       <p:pic>
         <p:nvPicPr>
-          <p:cNvPr id="3" name="Picture 2" descr="4-2.png"/>
+          <p:cNvPr id="3" name="Picture 2" descr="diagram-db.png"/>
           <p:cNvPicPr>
             <a:picLocks noChangeAspect="1"/>
           </p:cNvPicPr>
@@ -12414,7 +12414,7 @@
             </a:lvl9pPr>
           </a:lstStyle>
           <a:p>
-            <a:fld id="{D1F71EAB-0B02-4024-8668-902A24F29835}" type="slidenum">
+            <a:fld id="{96247E02-55BF-4381-9933-4C6B14ACF5DD}" type="slidenum">
               <a:t>6</a:t>
             </a:fld>
           </a:p>
@@ -12641,7 +12641,7 @@
             </a:lvl9pPr>
           </a:lstStyle>
           <a:p>
-            <a:fld id="{F1B2868B-6DF9-4D97-B65B-FAD4806A9BDE}" type="slidenum">
+            <a:fld id="{D37F42B3-67A4-43D5-A6B7-17DEB36BC9D8}" type="slidenum">
               <a:t>7</a:t>
             </a:fld>
           </a:p>
@@ -12808,7 +12808,7 @@
             </a:lvl9pPr>
           </a:lstStyle>
           <a:p>
-            <a:fld id="{C105D581-2758-47B7-BE79-53FAF1A688EF}" type="slidenum">
+            <a:fld id="{25FA595C-1485-4CEC-BA78-4683F7B97088}" type="slidenum">
               <a:t>8</a:t>
             </a:fld>
           </a:p>

</xml_diff>

<commit_message>
fix(thesis): one-line slide titles + full-res images in presentation
Image-slide titles set to 28pt so long "Контрольний приклад: …" titles
stay on one line; images start at 1.90" to clear even a 2-line title.
Drop per-kind downscaling (fit_screenshot/fit_diagram) for a single
fit_image that keeps full source resolution, capping only the longest
side at 4000px — fixes blurry diagrams and title overlap in PowerPoint.

Co-Authored-By: Claude Opus 4.7 (1M context) <noreply@anthropic.com>
</commit_message>
<xml_diff>
--- a/thesis/presentation.pptx
+++ b/thesis/presentation.pptx
@@ -9914,6 +9914,7 @@
           <a:lstStyle/>
           <a:p>
             <a:r>
+              <a:rPr sz="2800"/>
               <a:t>Контрольний приклад: публічна стрічка оголошень</a:t>
             </a:r>
           </a:p>
@@ -9935,8 +9936,8 @@
         </p:blipFill>
         <p:spPr>
           <a:xfrm>
-            <a:off x="2145792" y="1554480"/>
-            <a:ext cx="7900416" cy="4937760"/>
+            <a:off x="2365248" y="1737360"/>
+            <a:ext cx="7461504" cy="4663440"/>
           </a:xfrm>
           <a:prstGeom prst="rect">
             <a:avLst/>
@@ -10041,7 +10042,7 @@
             </a:lvl9pPr>
           </a:lstStyle>
           <a:p>
-            <a:fld id="{C664F19B-AAA8-4B0F-AB51-3466998EFDA6}" type="slidenum">
+            <a:fld id="{5E2991FD-87B9-4A5C-A62D-C3DC6AC0F34D}" type="slidenum">
               <a:t>9</a:t>
             </a:fld>
           </a:p>
@@ -10081,6 +10082,7 @@
           <a:lstStyle/>
           <a:p>
             <a:r>
+              <a:rPr sz="2800"/>
               <a:t>Контрольний приклад: форма публікації оголошення</a:t>
             </a:r>
           </a:p>
@@ -10102,8 +10104,8 @@
         </p:blipFill>
         <p:spPr>
           <a:xfrm>
-            <a:off x="2145792" y="1554480"/>
-            <a:ext cx="7900416" cy="4937760"/>
+            <a:off x="2365248" y="1737360"/>
+            <a:ext cx="7461504" cy="4663440"/>
           </a:xfrm>
           <a:prstGeom prst="rect">
             <a:avLst/>
@@ -10208,7 +10210,7 @@
             </a:lvl9pPr>
           </a:lstStyle>
           <a:p>
-            <a:fld id="{627D5FA5-D562-4D3D-B0C1-10EE516175F4}" type="slidenum">
+            <a:fld id="{B1187735-A8FF-4696-B0CC-20C5B0F0933E}" type="slidenum">
               <a:t>10</a:t>
             </a:fld>
           </a:p>
@@ -10248,6 +10250,7 @@
           <a:lstStyle/>
           <a:p>
             <a:r>
+              <a:rPr sz="2800"/>
               <a:t>Контрольний приклад: перелік кандидатів</a:t>
             </a:r>
           </a:p>
@@ -10269,8 +10272,8 @@
         </p:blipFill>
         <p:spPr>
           <a:xfrm>
-            <a:off x="2145792" y="1554480"/>
-            <a:ext cx="7900416" cy="4937760"/>
+            <a:off x="2365248" y="1737360"/>
+            <a:ext cx="7461504" cy="4663440"/>
           </a:xfrm>
           <a:prstGeom prst="rect">
             <a:avLst/>
@@ -10375,7 +10378,7 @@
             </a:lvl9pPr>
           </a:lstStyle>
           <a:p>
-            <a:fld id="{3530FC3A-5454-45FC-817A-55BA54E4C974}" type="slidenum">
+            <a:fld id="{722015DF-0110-4DF9-BB20-B7B92A1E5578}" type="slidenum">
               <a:t>11</a:t>
             </a:fld>
           </a:p>
@@ -10415,6 +10418,7 @@
           <a:lstStyle/>
           <a:p>
             <a:r>
+              <a:rPr sz="2800"/>
               <a:t>Контрольний приклад: підтверджений зв'язок</a:t>
             </a:r>
           </a:p>
@@ -10436,8 +10440,8 @@
         </p:blipFill>
         <p:spPr>
           <a:xfrm>
-            <a:off x="2145792" y="1554480"/>
-            <a:ext cx="7900416" cy="4937760"/>
+            <a:off x="2365248" y="1737360"/>
+            <a:ext cx="7461504" cy="4663440"/>
           </a:xfrm>
           <a:prstGeom prst="rect">
             <a:avLst/>
@@ -10542,7 +10546,7 @@
             </a:lvl9pPr>
           </a:lstStyle>
           <a:p>
-            <a:fld id="{58F868B0-A178-4A3B-BBAA-50E7909ADAE9}" type="slidenum">
+            <a:fld id="{2CD888B5-79F9-43D5-8A7F-FBEEDF811953}" type="slidenum">
               <a:t>12</a:t>
             </a:fld>
           </a:p>
@@ -10743,7 +10747,7 @@
             </a:lvl9pPr>
           </a:lstStyle>
           <a:p>
-            <a:fld id="{23DE5063-2074-4597-9FD6-D081839376EA}" type="slidenum">
+            <a:fld id="{2DF357E6-5590-4B5C-97F5-3D240EDC4C06}" type="slidenum">
               <a:t>13</a:t>
             </a:fld>
           </a:p>
@@ -10994,7 +10998,7 @@
             </a:lvl9pPr>
           </a:lstStyle>
           <a:p>
-            <a:fld id="{62DFF792-164E-4D60-B6ED-4475E6D66A99}" type="slidenum">
+            <a:fld id="{C84A8F4A-77E7-40D0-8851-675C4B20C8FA}" type="slidenum">
               <a:t>1</a:t>
             </a:fld>
           </a:p>
@@ -11165,7 +11169,7 @@
             </a:lvl9pPr>
           </a:lstStyle>
           <a:p>
-            <a:fld id="{E9CD3E03-0A1B-4E8D-8F3D-482F26F1C959}" type="slidenum">
+            <a:fld id="{43EFE717-6B5A-499F-90F8-117E335C6B8D}" type="slidenum">
               <a:t>2</a:t>
             </a:fld>
           </a:p>
@@ -11913,7 +11917,7 @@
             </a:lvl9pPr>
           </a:lstStyle>
           <a:p>
-            <a:fld id="{F1382105-3A9A-4626-8CD3-2DF9A4B7B7F7}" type="slidenum">
+            <a:fld id="{11A09889-9A70-4ED5-9164-814FAE32EF96}" type="slidenum">
               <a:t>3</a:t>
             </a:fld>
           </a:p>
@@ -11953,6 +11957,7 @@
           <a:lstStyle/>
           <a:p>
             <a:r>
+              <a:rPr sz="2800"/>
               <a:t>Діаграма варіантів використання системи</a:t>
             </a:r>
           </a:p>
@@ -11974,7 +11979,7 @@
         </p:blipFill>
         <p:spPr>
           <a:xfrm>
-            <a:off x="701040" y="2130995"/>
+            <a:off x="701040" y="2176715"/>
             <a:ext cx="10789920" cy="3784729"/>
           </a:xfrm>
           <a:prstGeom prst="rect">
@@ -12080,7 +12085,7 @@
             </a:lvl9pPr>
           </a:lstStyle>
           <a:p>
-            <a:fld id="{6EB323E4-730B-494B-BC72-55EC0C294DBD}" type="slidenum">
+            <a:fld id="{20E08A7D-D13D-4664-B2F5-6291CA26656B}" type="slidenum">
               <a:t>4</a:t>
             </a:fld>
           </a:p>
@@ -12120,6 +12125,7 @@
           <a:lstStyle/>
           <a:p>
             <a:r>
+              <a:rPr sz="2800"/>
               <a:t>Загальна архітектура вебзастосунку</a:t>
             </a:r>
           </a:p>
@@ -12141,8 +12147,8 @@
         </p:blipFill>
         <p:spPr>
           <a:xfrm>
-            <a:off x="3076340" y="1554480"/>
-            <a:ext cx="6039319" cy="4937760"/>
+            <a:off x="3244099" y="1737360"/>
+            <a:ext cx="5703801" cy="4663440"/>
           </a:xfrm>
           <a:prstGeom prst="rect">
             <a:avLst/>
@@ -12247,7 +12253,7 @@
             </a:lvl9pPr>
           </a:lstStyle>
           <a:p>
-            <a:fld id="{38CC5E90-4CB0-431E-AFDE-2FED6171BE78}" type="slidenum">
+            <a:fld id="{DCE94AC7-6253-4380-97BD-70CAD47EDF81}" type="slidenum">
               <a:t>5</a:t>
             </a:fld>
           </a:p>
@@ -12287,6 +12293,7 @@
           <a:lstStyle/>
           <a:p>
             <a:r>
+              <a:rPr sz="2800"/>
               <a:t>Схема бази даних («сутність — зв'язок»)</a:t>
             </a:r>
           </a:p>
@@ -12308,8 +12315,8 @@
         </p:blipFill>
         <p:spPr>
           <a:xfrm>
-            <a:off x="4616182" y="1554480"/>
-            <a:ext cx="2959635" cy="4937760"/>
+            <a:off x="4698394" y="1737360"/>
+            <a:ext cx="2795211" cy="4663440"/>
           </a:xfrm>
           <a:prstGeom prst="rect">
             <a:avLst/>
@@ -12414,7 +12421,7 @@
             </a:lvl9pPr>
           </a:lstStyle>
           <a:p>
-            <a:fld id="{96247E02-55BF-4381-9933-4C6B14ACF5DD}" type="slidenum">
+            <a:fld id="{22287187-60D5-45CF-BA9B-004E57B8CBC9}" type="slidenum">
               <a:t>6</a:t>
             </a:fld>
           </a:p>
@@ -12641,7 +12648,7 @@
             </a:lvl9pPr>
           </a:lstStyle>
           <a:p>
-            <a:fld id="{D37F42B3-67A4-43D5-A6B7-17DEB36BC9D8}" type="slidenum">
+            <a:fld id="{66C07458-2EA0-4D56-AC99-F9E45EE25F18}" type="slidenum">
               <a:t>7</a:t>
             </a:fld>
           </a:p>
@@ -12681,6 +12688,7 @@
           <a:lstStyle/>
           <a:p>
             <a:r>
+              <a:rPr sz="2800"/>
               <a:t>Контрольний приклад: авторизація користувача</a:t>
             </a:r>
           </a:p>
@@ -12702,8 +12710,8 @@
         </p:blipFill>
         <p:spPr>
           <a:xfrm>
-            <a:off x="2145792" y="1554480"/>
-            <a:ext cx="7900416" cy="4937760"/>
+            <a:off x="2365248" y="1737360"/>
+            <a:ext cx="7461504" cy="4663440"/>
           </a:xfrm>
           <a:prstGeom prst="rect">
             <a:avLst/>
@@ -12808,7 +12816,7 @@
             </a:lvl9pPr>
           </a:lstStyle>
           <a:p>
-            <a:fld id="{25FA595C-1485-4CEC-BA78-4683F7B97088}" type="slidenum">
+            <a:fld id="{9FA7BA16-A06B-4D2F-BA7D-1AB84A4F70BB}" type="slidenum">
               <a:t>8</a:t>
             </a:fld>
           </a:p>

</xml_diff>

<commit_message>
fix(thesis): rework deck + thesis content; restructure practice docs
Presentation (this session):
- pull goal/object/subject + all 9 tasks verbatim from 03-vstup.md
- add experiment-results slide, refresh conclusions to cite it
- fix slide 2 «Мета і задачі» and slide 15 «Загальні висновки» overflow:
  enlarge body to full content area, set all four geometry fields
  (top/height alone collapsed the inherited placeholder to zero width)

Thesis: committee-review fixes across rozdil 1-7, vstup, conclusions,
anotaciya, zmist, sources, dodatky; updated build/render scripts.

Practice: rename build_practice.py -> build_shodennyk.py; drop the zvit
doc set and stale practice artifacts; rename related skills.

No apps/client or apps/server code touched -> pnpm verify N/A.

Co-Authored-By: Claude Opus 4.8 <noreply@anthropic.com>
</commit_message>
<xml_diff>
--- a/thesis/presentation.pptx
+++ b/thesis/presentation.pptx
@@ -22,6 +22,7 @@
     <p:sldId id="267" r:id="rId2"/>
     <p:sldId id="268" r:id="rId27"/>
     <p:sldId id="269" r:id="rId28"/>
+    <p:sldId id="270" r:id="rId29"/>
   </p:sldIdLst>
   <p:sldSz cx="12192000" cy="6858000"/>
   <p:notesSz cx="6858000" cy="9144000"/>
@@ -1861,7 +1862,77 @@
           <a:lstStyle/>
           <a:p>
             <a:r>
-              <a:t>Підсумую. Я розробив вебзастосунок, який автоматизує найтрудомісткіший етап пошуку — виявлення ймовірного збігу, і захищає контакти до підтвердження. Ключовий результат — алгоритм зіставлення на формулі гаверсинуса з лексикографічним упорядкуванням. Систему перевірено: 130 серверних і 44 клієнтських тести проходять, конвеєр зелений. Поставлені задачі виконано, мету роботи досягнуто. Дякую за увагу, готовий відповісти на запитання.</a:t>
+              <a:t>Щоб показати, що мету досягнуто, я провів експеримент на модельному наборі: шістдесят пар втрата–знахідка з відомими збігами плюс сто сорок сторонніх оголошень, усе відтворюється за фіксованим сидом. Істинний збіг потрапляє в перші три позиції в усіх запитах, на першу — у вісімдесяти двох відсотках, середній обернений ранг дорівнює нуль цілих дев'яносто одна. Порівняно з хронологічним переглядом це приблизно стократне скорочення обсягу перегляду. Час формування переліку для п'ятдесяти тисяч оголошень — до п'ятдесяти мілісекунд, тобто вимога у дві секунди виконується із запасом.</a:t>
+            </a:r>
+          </a:p>
+        </p:txBody>
+      </p:sp>
+      <p:sp>
+        <p:nvSpPr>
+          <p:cNvPr id="4" name="Slide Number Placeholder 3"/>
+          <p:cNvSpPr>
+            <a:spLocks noGrp="1"/>
+          </p:cNvSpPr>
+          <p:nvPr>
+            <p:ph type="sldNum" idx="12"/>
+          </p:nvPr>
+        </p:nvSpPr>
+        <p:spPr/>
+      </p:sp>
+    </p:spTree>
+  </p:cSld>
+  <p:clrMapOvr>
+    <a:masterClrMapping/>
+  </p:clrMapOvr>
+</p:notes>
+</file>
+
+<file path=ppt/notesSlides/notesSlide15.xml><?xml version="1.0" encoding="utf-8"?>
+<p:notes xmlns:a="http://schemas.openxmlformats.org/drawingml/2006/main" xmlns:p="http://schemas.openxmlformats.org/presentationml/2006/main" xmlns:r="http://schemas.openxmlformats.org/officeDocument/2006/relationships">
+  <p:cSld>
+    <p:spTree>
+      <p:nvGrpSpPr>
+        <p:cNvPr id="1" name=""/>
+        <p:cNvGrpSpPr/>
+        <p:nvPr/>
+      </p:nvGrpSpPr>
+      <p:grpSpPr>
+        <a:xfrm>
+          <a:off x="0" y="0"/>
+          <a:ext cx="0" cy="0"/>
+          <a:chOff x="0" y="0"/>
+          <a:chExt cx="0" cy="0"/>
+        </a:xfrm>
+      </p:grpSpPr>
+      <p:sp>
+        <p:nvSpPr>
+          <p:cNvPr id="2" name="Slide Image Placeholder 1"/>
+          <p:cNvSpPr>
+            <a:spLocks noGrp="1"/>
+          </p:cNvSpPr>
+          <p:nvPr>
+            <p:ph type="sldImg" idx="3"/>
+          </p:nvPr>
+        </p:nvSpPr>
+        <p:spPr/>
+      </p:sp>
+      <p:sp>
+        <p:nvSpPr>
+          <p:cNvPr id="3" name="Notes Placeholder 2"/>
+          <p:cNvSpPr>
+            <a:spLocks noGrp="1"/>
+          </p:cNvSpPr>
+          <p:nvPr>
+            <p:ph type="body" idx="1"/>
+          </p:nvPr>
+        </p:nvSpPr>
+        <p:spPr/>
+        <p:txBody>
+          <a:bodyPr/>
+          <a:lstStyle/>
+          <a:p>
+            <a:r>
+              <a:t>Підсумую. Я розробив вебзастосунок, який автоматизує найтрудомісткіший етап пошуку — виявлення ймовірного збігу, і захищає контакти до підтвердження. Ключовий результат — алгоритм зіставлення на формулі гаверсинуса з лексикографічним упорядкуванням. Систему перевірено: 130 серверних і 44 клієнтських тести проходять. А досягнення мети підтверджено експериментально — істинний збіг у перших трьох позиціях у всіх запитах, час до п'ятдесяти мілісекунд на п'ятдесяти тисячах оголошень. Поставлені задачі виконано, мету роботи досягнуто. Дякую за увагу, готовий відповісти на запитання.</a:t>
             </a:r>
           </a:p>
         </p:txBody>
@@ -1931,7 +2002,7 @@
           <a:lstStyle/>
           <a:p>
             <a:r>
-              <a:t>Коли тварина губиться, все вирішують перші дні. Власники й ті, хто знайшов тварину, шукають одне одного вручну — у різних чатах, групах, на OLX, і оголошення ніяк не зіставляються між собою. Тому мета роботи — скоротити час возз'єднання за рахунок автоматичного зіставлення оголошень про втрату та про знахідку. Щоб цього досягти, я розбив роботу на вісім задач: від дослідження області й аналізу аналогів до алгоритму зіставлення, проєктування, реалізації та тестування.</a:t>
+              <a:t>Коли тварина губиться, вирішують перші дні, а власник і той, хто знайшов тварину, шукають одне одного вручну в різних чатах і на OLX — оголошення ніде не зіставляються. Тому мета роботи — підвищити ефективність первинного зіставлення: розробити вебзастосунок, що сам формує ранжований перелік ймовірних збігів. Ефективність я міряю двома величинами — якістю ранжування і часом формування переліку, і досягнення мети підтверджую експериментом. Щоб дійти до цього, роботу розбито на дев'ять задач: від аналізу області й аналогів до алгоритму зіставлення, проєктування, реалізації, тестування і самого експерименту.</a:t>
             </a:r>
           </a:p>
         </p:txBody>
@@ -2001,7 +2072,7 @@
           <a:lstStyle/>
           <a:p>
             <a:r>
-              <a:t>Якщо коротко: об'єкт — це сам процес пошуку й повернення тварин через зіставлення втрати та знахідки. А предмет — те, що я безпосередньо будую: моделі, алгоритм і програмні засоби, які структуровано подають оголошення й формують ранжований перелік ймовірних збігів. Важливо, що остаточне рішення про збіг приймає людина, а не система.</a:t>
+              <a:t>Об'єкт роботи — це процес автоматизації зіставлення оголошень про загублених і знайдених тварин засобами вебзастосунку, тобто інженерна задача, а не сам пошук тварин. Предмет — те, що я безпосередньо будую: моделі, алгоритм і програмні засоби, які структуровано подають оголошення й формують ранжований перелік ймовірних збігів. Остаточне рішення про збіг приймає людина, а не система.</a:t>
             </a:r>
           </a:p>
         </p:txBody>
@@ -9850,31 +9921,31 @@
           <a:lstStyle/>
           <a:p>
             <a:r>
-              <a:rPr b="1" sz="1600"/>
+              <a:rPr b="1" sz="2200"/>
               <a:t>Кваліфікаційна робота бакалавра</a:t>
             </a:r>
           </a:p>
           <a:p>
             <a:r>
-              <a:rPr b="0" sz="1400"/>
+              <a:rPr b="0" sz="1800"/>
               <a:t>Виконав: ст. гр. АС-222 Ілля Вербанов</a:t>
             </a:r>
           </a:p>
           <a:p>
             <a:r>
-              <a:rPr b="0" sz="1400"/>
+              <a:rPr b="0" sz="1800"/>
               <a:t>Керівник: Надія Беглова, асистент каф. ІПЗ</a:t>
             </a:r>
           </a:p>
           <a:p>
             <a:r>
-              <a:rPr b="0" sz="1400"/>
+              <a:rPr b="0" sz="1800"/>
               <a:t>Національний університет «Одеська політехніка»</a:t>
             </a:r>
           </a:p>
           <a:p>
             <a:r>
-              <a:rPr b="0" sz="1400"/>
+              <a:rPr b="0" sz="1800"/>
               <a:t>Одеса – 2026</a:t>
             </a:r>
           </a:p>
@@ -9956,8 +10027,8 @@
         </p:nvSpPr>
         <p:spPr>
           <a:xfrm>
-            <a:off x="11280575" y="6201587"/>
-            <a:ext cx="731700" cy="524700"/>
+            <a:off x="11155680" y="137160"/>
+            <a:ext cx="731520" cy="365760"/>
           </a:xfrm>
           <a:prstGeom prst="rect">
             <a:avLst/>
@@ -10042,7 +10113,8 @@
             </a:lvl9pPr>
           </a:lstStyle>
           <a:p>
-            <a:fld id="{5E2991FD-87B9-4A5C-A62D-C3DC6AC0F34D}" type="slidenum">
+            <a:pPr algn="r"/>
+            <a:fld id="{B4F93DBF-BE95-4BD3-A1DE-919D28F89477}" type="slidenum">
               <a:t>9</a:t>
             </a:fld>
           </a:p>
@@ -10124,8 +10196,8 @@
         </p:nvSpPr>
         <p:spPr>
           <a:xfrm>
-            <a:off x="11280575" y="6201587"/>
-            <a:ext cx="731700" cy="524700"/>
+            <a:off x="11155680" y="137160"/>
+            <a:ext cx="731520" cy="365760"/>
           </a:xfrm>
           <a:prstGeom prst="rect">
             <a:avLst/>
@@ -10210,7 +10282,8 @@
             </a:lvl9pPr>
           </a:lstStyle>
           <a:p>
-            <a:fld id="{B1187735-A8FF-4696-B0CC-20C5B0F0933E}" type="slidenum">
+            <a:pPr algn="r"/>
+            <a:fld id="{6D8F1B54-C31D-4555-B398-C4F25532C8DD}" type="slidenum">
               <a:t>10</a:t>
             </a:fld>
           </a:p>
@@ -10292,8 +10365,8 @@
         </p:nvSpPr>
         <p:spPr>
           <a:xfrm>
-            <a:off x="11280575" y="6201587"/>
-            <a:ext cx="731700" cy="524700"/>
+            <a:off x="11155680" y="137160"/>
+            <a:ext cx="731520" cy="365760"/>
           </a:xfrm>
           <a:prstGeom prst="rect">
             <a:avLst/>
@@ -10378,7 +10451,8 @@
             </a:lvl9pPr>
           </a:lstStyle>
           <a:p>
-            <a:fld id="{722015DF-0110-4DF9-BB20-B7B92A1E5578}" type="slidenum">
+            <a:pPr algn="r"/>
+            <a:fld id="{7F24967F-BC31-4E1C-8575-E6D88353DE36}" type="slidenum">
               <a:t>11</a:t>
             </a:fld>
           </a:p>
@@ -10460,8 +10534,8 @@
         </p:nvSpPr>
         <p:spPr>
           <a:xfrm>
-            <a:off x="11280575" y="6201587"/>
-            <a:ext cx="731700" cy="524700"/>
+            <a:off x="11155680" y="137160"/>
+            <a:ext cx="731520" cy="365760"/>
           </a:xfrm>
           <a:prstGeom prst="rect">
             <a:avLst/>
@@ -10546,7 +10620,8 @@
             </a:lvl9pPr>
           </a:lstStyle>
           <a:p>
-            <a:fld id="{2CD888B5-79F9-43D5-8A7F-FBEEDF811953}" type="slidenum">
+            <a:pPr algn="r"/>
+            <a:fld id="{28075809-4647-4500-802C-8591566D5811}" type="slidenum">
               <a:t>12</a:t>
             </a:fld>
           </a:p>
@@ -10561,6 +10636,387 @@
 </file>
 
 <file path=ppt/slides/slide14.xml><?xml version="1.0" encoding="utf-8"?>
+<p:sld xmlns:a="http://schemas.openxmlformats.org/drawingml/2006/main" xmlns:p="http://schemas.openxmlformats.org/presentationml/2006/main" xmlns:r="http://schemas.openxmlformats.org/officeDocument/2006/relationships">
+  <p:cSld>
+    <p:spTree>
+      <p:nvGrpSpPr>
+        <p:cNvPr id="1" name=""/>
+        <p:cNvGrpSpPr/>
+        <p:nvPr/>
+      </p:nvGrpSpPr>
+      <p:grpSpPr/>
+      <p:sp>
+        <p:nvSpPr>
+          <p:cNvPr id="2" name="Title 1"/>
+          <p:cNvSpPr>
+            <a:spLocks noGrp="1"/>
+          </p:cNvSpPr>
+          <p:nvPr>
+            <p:ph type="title"/>
+          </p:nvPr>
+        </p:nvSpPr>
+        <p:spPr/>
+        <p:txBody>
+          <a:bodyPr/>
+          <a:lstStyle/>
+          <a:p>
+            <a:r>
+              <a:rPr sz="2400"/>
+              <a:t>Експериментальне дослідження ефективності зіставлення</a:t>
+            </a:r>
+          </a:p>
+        </p:txBody>
+      </p:sp>
+      <p:graphicFrame>
+        <p:nvGraphicFramePr>
+          <p:cNvPr id="3" name="Table 2"/>
+          <p:cNvGraphicFramePr>
+            <a:graphicFrameLocks noGrp="1"/>
+          </p:cNvGraphicFramePr>
+          <p:nvPr/>
+        </p:nvGraphicFramePr>
+        <p:xfrm>
+          <a:off x="2194560" y="1554480"/>
+          <a:ext cx="7772400" cy="4023360"/>
+        </p:xfrm>
+        <a:graphic>
+          <a:graphicData uri="http://schemas.openxmlformats.org/drawingml/2006/table">
+            <a:tbl>
+              <a:tblPr firstRow="1" bandRow="1">
+                <a:tableStyleId>{5C22544A-7EE6-4342-B048-85BDC9FD1C3A}</a:tableStyleId>
+              </a:tblPr>
+              <a:tblGrid>
+                <a:gridCol w="5212080"/>
+                <a:gridCol w="2560320"/>
+              </a:tblGrid>
+              <a:tr h="574765">
+                <a:tc>
+                  <a:txBody>
+                    <a:bodyPr/>
+                    <a:lstStyle/>
+                    <a:p>
+                      <a:pPr algn="ctr"/>
+                      <a:r>
+                        <a:rPr b="1" sz="1800"/>
+                        <a:t>Показник</a:t>
+                      </a:r>
+                    </a:p>
+                  </a:txBody>
+                  <a:tcPr/>
+                </a:tc>
+                <a:tc>
+                  <a:txBody>
+                    <a:bodyPr/>
+                    <a:lstStyle/>
+                    <a:p>
+                      <a:pPr algn="ctr"/>
+                      <a:r>
+                        <a:rPr b="1" sz="1800"/>
+                        <a:t>Значення</a:t>
+                      </a:r>
+                    </a:p>
+                  </a:txBody>
+                  <a:tcPr/>
+                </a:tc>
+              </a:tr>
+              <a:tr h="574765">
+                <a:tc>
+                  <a:txBody>
+                    <a:bodyPr/>
+                    <a:lstStyle/>
+                    <a:p>
+                      <a:pPr algn="l"/>
+                      <a:r>
+                        <a:rPr sz="1800"/>
+                        <a:t>Hit@1 — істинний збіг на першій позиції</a:t>
+                      </a:r>
+                    </a:p>
+                  </a:txBody>
+                  <a:tcPr/>
+                </a:tc>
+                <a:tc>
+                  <a:txBody>
+                    <a:bodyPr/>
+                    <a:lstStyle/>
+                    <a:p>
+                      <a:pPr algn="ctr"/>
+                      <a:r>
+                        <a:rPr sz="1800"/>
+                        <a:t>0,82</a:t>
+                      </a:r>
+                    </a:p>
+                  </a:txBody>
+                  <a:tcPr/>
+                </a:tc>
+              </a:tr>
+              <a:tr h="574765">
+                <a:tc>
+                  <a:txBody>
+                    <a:bodyPr/>
+                    <a:lstStyle/>
+                    <a:p>
+                      <a:pPr algn="l"/>
+                      <a:r>
+                        <a:rPr sz="1800"/>
+                        <a:t>Hit@3 / Hit@5 — у перших трьох / п'яти</a:t>
+                      </a:r>
+                    </a:p>
+                  </a:txBody>
+                  <a:tcPr/>
+                </a:tc>
+                <a:tc>
+                  <a:txBody>
+                    <a:bodyPr/>
+                    <a:lstStyle/>
+                    <a:p>
+                      <a:pPr algn="ctr"/>
+                      <a:r>
+                        <a:rPr sz="1800"/>
+                        <a:t>1,00 / 1,00</a:t>
+                      </a:r>
+                    </a:p>
+                  </a:txBody>
+                  <a:tcPr/>
+                </a:tc>
+              </a:tr>
+              <a:tr h="574765">
+                <a:tc>
+                  <a:txBody>
+                    <a:bodyPr/>
+                    <a:lstStyle/>
+                    <a:p>
+                      <a:pPr algn="l"/>
+                      <a:r>
+                        <a:rPr sz="1800"/>
+                        <a:t>Середній обернений ранг (MRR)</a:t>
+                      </a:r>
+                    </a:p>
+                  </a:txBody>
+                  <a:tcPr/>
+                </a:tc>
+                <a:tc>
+                  <a:txBody>
+                    <a:bodyPr/>
+                    <a:lstStyle/>
+                    <a:p>
+                      <a:pPr algn="ctr"/>
+                      <a:r>
+                        <a:rPr sz="1800"/>
+                        <a:t>0,91</a:t>
+                      </a:r>
+                    </a:p>
+                  </a:txBody>
+                  <a:tcPr/>
+                </a:tc>
+              </a:tr>
+              <a:tr h="574765">
+                <a:tc>
+                  <a:txBody>
+                    <a:bodyPr/>
+                    <a:lstStyle/>
+                    <a:p>
+                      <a:pPr algn="l"/>
+                      <a:r>
+                        <a:rPr sz="1800"/>
+                        <a:t>Медіанний ранг істинного збігу</a:t>
+                      </a:r>
+                    </a:p>
+                  </a:txBody>
+                  <a:tcPr/>
+                </a:tc>
+                <a:tc>
+                  <a:txBody>
+                    <a:bodyPr/>
+                    <a:lstStyle/>
+                    <a:p>
+                      <a:pPr algn="ctr"/>
+                      <a:r>
+                        <a:rPr sz="1800"/>
+                        <a:t>1</a:t>
+                      </a:r>
+                    </a:p>
+                  </a:txBody>
+                  <a:tcPr/>
+                </a:tc>
+              </a:tr>
+              <a:tr h="574765">
+                <a:tc>
+                  <a:txBody>
+                    <a:bodyPr/>
+                    <a:lstStyle/>
+                    <a:p>
+                      <a:pPr algn="l"/>
+                      <a:r>
+                        <a:rPr sz="1800"/>
+                        <a:t>Час формування переліку (50 000 оголошень)</a:t>
+                      </a:r>
+                    </a:p>
+                  </a:txBody>
+                  <a:tcPr/>
+                </a:tc>
+                <a:tc>
+                  <a:txBody>
+                    <a:bodyPr/>
+                    <a:lstStyle/>
+                    <a:p>
+                      <a:pPr algn="ctr"/>
+                      <a:r>
+                        <a:rPr sz="1800"/>
+                        <a:t>≤ 50 мс</a:t>
+                      </a:r>
+                    </a:p>
+                  </a:txBody>
+                  <a:tcPr/>
+                </a:tc>
+              </a:tr>
+              <a:tr h="574770">
+                <a:tc>
+                  <a:txBody>
+                    <a:bodyPr/>
+                    <a:lstStyle/>
+                    <a:p>
+                      <a:pPr algn="l"/>
+                      <a:r>
+                        <a:rPr sz="1800"/>
+                        <a:t>Скорочення обсягу перегляду vs хронологічний</a:t>
+                      </a:r>
+                    </a:p>
+                  </a:txBody>
+                  <a:tcPr/>
+                </a:tc>
+                <a:tc>
+                  <a:txBody>
+                    <a:bodyPr/>
+                    <a:lstStyle/>
+                    <a:p>
+                      <a:pPr algn="ctr"/>
+                      <a:r>
+                        <a:rPr sz="1800"/>
+                        <a:t>≈ 100×</a:t>
+                      </a:r>
+                    </a:p>
+                  </a:txBody>
+                  <a:tcPr/>
+                </a:tc>
+              </a:tr>
+            </a:tbl>
+          </a:graphicData>
+        </a:graphic>
+      </p:graphicFrame>
+      <p:sp>
+        <p:nvSpPr>
+          <p:cNvPr id="49" name="Google Shape;49;p6"/>
+          <p:cNvSpPr txBox="1">
+            <a:spLocks noGrp="1"/>
+          </p:cNvSpPr>
+          <p:nvPr>
+            <p:ph type="sldNum" idx="12"/>
+          </p:nvPr>
+        </p:nvSpPr>
+        <p:spPr>
+          <a:xfrm>
+            <a:off x="11155680" y="137160"/>
+            <a:ext cx="731520" cy="365760"/>
+          </a:xfrm>
+          <a:prstGeom prst="rect">
+            <a:avLst/>
+          </a:prstGeom>
+        </p:spPr>
+        <p:txBody>
+          <a:bodyPr spcFirstLastPara="1" wrap="square" lIns="121900" tIns="121900" rIns="121900" bIns="121900" anchor="ctr" anchorCtr="0">
+            <a:normAutofit/>
+          </a:bodyPr>
+          <a:lstStyle>
+            <a:lvl1pPr lvl="0">
+              <a:buNone/>
+              <a:defRPr>
+                <a:solidFill>
+                  <a:schemeClr val="dk2"/>
+                </a:solidFill>
+              </a:defRPr>
+            </a:lvl1pPr>
+            <a:lvl2pPr lvl="1">
+              <a:buNone/>
+              <a:defRPr>
+                <a:solidFill>
+                  <a:schemeClr val="dk2"/>
+                </a:solidFill>
+              </a:defRPr>
+            </a:lvl2pPr>
+            <a:lvl3pPr lvl="2">
+              <a:buNone/>
+              <a:defRPr>
+                <a:solidFill>
+                  <a:schemeClr val="dk2"/>
+                </a:solidFill>
+              </a:defRPr>
+            </a:lvl3pPr>
+            <a:lvl4pPr lvl="3">
+              <a:buNone/>
+              <a:defRPr>
+                <a:solidFill>
+                  <a:schemeClr val="dk2"/>
+                </a:solidFill>
+              </a:defRPr>
+            </a:lvl4pPr>
+            <a:lvl5pPr lvl="4">
+              <a:buNone/>
+              <a:defRPr>
+                <a:solidFill>
+                  <a:schemeClr val="dk2"/>
+                </a:solidFill>
+              </a:defRPr>
+            </a:lvl5pPr>
+            <a:lvl6pPr lvl="5">
+              <a:buNone/>
+              <a:defRPr>
+                <a:solidFill>
+                  <a:schemeClr val="dk2"/>
+                </a:solidFill>
+              </a:defRPr>
+            </a:lvl6pPr>
+            <a:lvl7pPr lvl="6">
+              <a:buNone/>
+              <a:defRPr>
+                <a:solidFill>
+                  <a:schemeClr val="dk2"/>
+                </a:solidFill>
+              </a:defRPr>
+            </a:lvl7pPr>
+            <a:lvl8pPr lvl="7">
+              <a:buNone/>
+              <a:defRPr>
+                <a:solidFill>
+                  <a:schemeClr val="dk2"/>
+                </a:solidFill>
+              </a:defRPr>
+            </a:lvl8pPr>
+            <a:lvl9pPr lvl="8">
+              <a:buNone/>
+              <a:defRPr>
+                <a:solidFill>
+                  <a:schemeClr val="dk2"/>
+                </a:solidFill>
+              </a:defRPr>
+            </a:lvl9pPr>
+          </a:lstStyle>
+          <a:p>
+            <a:pPr algn="r"/>
+            <a:fld id="{721E311A-CE1C-4530-99F7-98E6AE90E3D4}" type="slidenum">
+              <a:t>13</a:t>
+            </a:fld>
+          </a:p>
+        </p:txBody>
+      </p:sp>
+    </p:spTree>
+  </p:cSld>
+  <p:clrMapOvr>
+    <a:masterClrMapping/>
+  </p:clrMapOvr>
+</p:sld>
+</file>
+
+<file path=ppt/slides/slide15.xml><?xml version="1.0" encoding="utf-8"?>
 <p:sld xmlns:a="http://schemas.openxmlformats.org/drawingml/2006/main" xmlns:p="http://schemas.openxmlformats.org/presentationml/2006/main" xmlns:r="http://schemas.openxmlformats.org/officeDocument/2006/relationships">
   <p:cSld>
     <p:spTree>
@@ -10601,85 +11057,124 @@
             <p:ph type="body" idx="1"/>
           </p:nvPr>
         </p:nvSpPr>
-        <p:spPr/>
+        <p:spPr>
+          <a:xfrm>
+            <a:off x="416052" y="1417320"/>
+            <a:ext cx="11360505" cy="5166360"/>
+          </a:xfrm>
+        </p:spPr>
         <p:txBody>
           <a:bodyPr wrap="square"/>
           <a:lstStyle/>
           <a:p>
             <a:pPr algn="l" marL="342900" indent="-342900">
-              <a:spcAft>
-                <a:spcPts val="600"/>
+              <a:lnSpc>
+                <a:spcPct val="100000"/>
+              </a:lnSpc>
+              <a:spcAft>
+                <a:spcPts val="400"/>
               </a:spcAft>
               <a:buFont typeface="Arial"/>
               <a:buChar char="•"/>
             </a:pPr>
             <a:r>
-              <a:rPr sz="1400" b="0"/>
-              <a:t>У кваліфікаційній роботі вирішено задачу розробки вебзастосунку для пошуку загублених домашніх тварин шляхом автоматизованого зіставлення оголошень про втрату та про знахідку.</a:t>
+              <a:rPr sz="1800" b="0"/>
+              <a:t>Розроблено вебзастосунок для пошуку загублених тварин через автоматичне зіставлення оголошень про втрату та про знахідку.</a:t>
             </a:r>
           </a:p>
           <a:p>
             <a:pPr algn="l" marL="342900" indent="-342900">
-              <a:spcAft>
-                <a:spcPts val="600"/>
+              <a:lnSpc>
+                <a:spcPct val="100000"/>
+              </a:lnSpc>
+              <a:spcAft>
+                <a:spcPts val="400"/>
               </a:spcAft>
               <a:buFont typeface="Arial"/>
               <a:buChar char="•"/>
             </a:pPr>
             <a:r>
-              <a:rPr sz="1400" b="0"/>
-              <a:t>Аналіз аналогів — сервісу PawBoost, бази Pet FBI та тематичних спільнот — показав, що жодне з рішень не виконує автоматичного зіставлення, не ранжує ймовірні збіги і не приховує контактні дані до підтвердження.</a:t>
+              <a:rPr sz="1800" b="0"/>
+              <a:t>Аналіз аналогів (PawBoost, Pet FBI, спільноти): жоден не зіставляє автоматично, не ранжує збіги й не приховує контакти до підтвердження.</a:t>
             </a:r>
           </a:p>
           <a:p>
             <a:pPr algn="l" marL="342900" indent="-342900">
-              <a:spcAft>
-                <a:spcPts val="600"/>
+              <a:lnSpc>
+                <a:spcPct val="100000"/>
+              </a:lnSpc>
+              <a:spcAft>
+                <a:spcPts val="400"/>
               </a:spcAft>
               <a:buFont typeface="Arial"/>
               <a:buChar char="•"/>
             </a:pPr>
             <a:r>
-              <a:rPr sz="1400" b="0"/>
-              <a:t>Для обчислення відстані застосовано формулу гаверсинуса, для впорядкування кандидатів — лексикографічне правило, що відображає природний пріоритет ознак.</a:t>
+              <a:rPr sz="1800" b="0"/>
+              <a:t>Ключовий результат — алгоритм зіставлення: гаверсинус для відстані та лексикографічне ранжування кандидатів; остаточне рішення про збіг — за людиною.</a:t>
             </a:r>
           </a:p>
           <a:p>
             <a:pPr algn="l" marL="342900" indent="-342900">
-              <a:spcAft>
-                <a:spcPts val="600"/>
+              <a:lnSpc>
+                <a:spcPct val="100000"/>
+              </a:lnSpc>
+              <a:spcAft>
+                <a:spcPts val="400"/>
               </a:spcAft>
               <a:buFont typeface="Arial"/>
               <a:buChar char="•"/>
             </a:pPr>
             <a:r>
-              <a:rPr sz="1400" b="0"/>
-              <a:t>На основі проєктних рішень реалізовано вебзастосунок із використанням платформи Node.js, фреймворку NestJS, бібліотеки React, ORM Drizzle та системи керування базами даних PostgreSQL.</a:t>
+              <a:rPr sz="1800" b="0"/>
+              <a:t>Реалізовано за принципом портів і адаптерів на Node.js, NestJS, React, Drizzle та PostgreSQL; контакти приховано до підтвердження зв'язку.</a:t>
             </a:r>
           </a:p>
           <a:p>
             <a:pPr algn="l" marL="342900" indent="-342900">
-              <a:spcAft>
-                <a:spcPts val="600"/>
+              <a:lnSpc>
+                <a:spcPct val="100000"/>
+              </a:lnSpc>
+              <a:spcAft>
+                <a:spcPts val="400"/>
               </a:spcAft>
               <a:buFont typeface="Arial"/>
               <a:buChar char="•"/>
             </a:pPr>
             <a:r>
-              <a:rPr sz="1400" b="0"/>
-              <a:t>автоматизований набір із 130 серверних і 44 клієнтських тестів проходить успішно, єдиний конвеєр перевірки завершується без помилок.</a:t>
+              <a:rPr sz="1800" b="0"/>
+              <a:t>Тестування: 130 серверних і 44 клієнтських тести проходять, єдиний конвеєр перевірки завершується без помилок.</a:t>
             </a:r>
           </a:p>
           <a:p>
             <a:pPr algn="l" marL="342900" indent="-342900">
-              <a:spcAft>
-                <a:spcPts val="600"/>
+              <a:lnSpc>
+                <a:spcPct val="100000"/>
+              </a:lnSpc>
+              <a:spcAft>
+                <a:spcPts val="400"/>
               </a:spcAft>
               <a:buFont typeface="Arial"/>
               <a:buChar char="•"/>
             </a:pPr>
             <a:r>
-              <a:rPr sz="1400" b="0"/>
+              <a:rPr sz="1800" b="0"/>
+              <a:t>Досягнення мети підтверджено експериментально: істинний збіг у перших трьох позиціях у всіх запитах (Hit@3 = 1,00), MRR = 0,91; час формування переліку для 50 000 оголошень ≤ 50 мс, тобто в межах вимоги у 2 с.</a:t>
+            </a:r>
+          </a:p>
+          <a:p>
+            <a:pPr algn="l" marL="342900" indent="-342900">
+              <a:lnSpc>
+                <a:spcPct val="100000"/>
+              </a:lnSpc>
+              <a:spcAft>
+                <a:spcPts val="400"/>
+              </a:spcAft>
+              <a:buFont typeface="Arial"/>
+              <a:buChar char="•"/>
+            </a:pPr>
+            <a:r>
+              <a:rPr sz="1800" b="0"/>
               <a:t>Поставлені в роботі задачі виконано повністю, мету роботи досягнуто.</a:t>
             </a:r>
           </a:p>
@@ -10697,8 +11192,8 @@
         </p:nvSpPr>
         <p:spPr>
           <a:xfrm>
-            <a:off x="11280575" y="6201587"/>
-            <a:ext cx="731700" cy="524700"/>
+            <a:off x="11155680" y="137160"/>
+            <a:ext cx="731520" cy="365760"/>
           </a:xfrm>
           <a:prstGeom prst="rect">
             <a:avLst/>
@@ -10747,8 +11242,9 @@
             </a:lvl9pPr>
           </a:lstStyle>
           <a:p>
-            <a:fld id="{2DF357E6-5590-4B5C-97F5-3D240EDC4C06}" type="slidenum">
-              <a:t>13</a:t>
+            <a:pPr algn="r"/>
+            <a:fld id="{48DC4FE4-B20C-461E-A3B5-0493ACFF3569}" type="slidenum">
+              <a:t>14</a:t>
             </a:fld>
           </a:p>
         </p:txBody>
@@ -10802,136 +11298,187 @@
             <p:ph type="body" idx="1"/>
           </p:nvPr>
         </p:nvSpPr>
-        <p:spPr/>
+        <p:spPr>
+          <a:xfrm>
+            <a:off x="416052" y="1417320"/>
+            <a:ext cx="11360505" cy="5166360"/>
+          </a:xfrm>
+        </p:spPr>
         <p:txBody>
           <a:bodyPr wrap="square"/>
           <a:lstStyle/>
           <a:p>
             <a:pPr algn="l">
-              <a:spcAft>
-                <a:spcPts val="800"/>
+              <a:lnSpc>
+                <a:spcPct val="100000"/>
+              </a:lnSpc>
+              <a:spcAft>
+                <a:spcPts val="400"/>
               </a:spcAft>
               <a:buNone/>
             </a:pPr>
             <a:r>
-              <a:rPr sz="1500" b="1"/>
-              <a:t>Метою роботи є скорочення часу возз'єднання загублених домашніх тварин з власниками за рахунок автоматизації первинного зіставлення оголошень про втрату та про знахідку.</a:t>
+              <a:rPr sz="1800" b="1"/>
+              <a:t>Метою роботи є підвищення ефективності первинного зіставлення оголошень про загублених і знайдених домашніх тварин шляхом розроблення вебзастосунку, що автоматично формує ранжований перелік ймовірних збігів.</a:t>
             </a:r>
           </a:p>
           <a:p>
             <a:pPr algn="l">
-              <a:spcAft>
-                <a:spcPts val="600"/>
+              <a:lnSpc>
+                <a:spcPct val="100000"/>
+              </a:lnSpc>
+              <a:spcAft>
+                <a:spcPts val="200"/>
               </a:spcAft>
               <a:buNone/>
             </a:pPr>
             <a:r>
-              <a:rPr sz="1400" b="0"/>
+              <a:rPr sz="1800" b="0"/>
               <a:t>Для досягнення поставленої мети необхідно вирішити такі задачі:</a:t>
             </a:r>
           </a:p>
           <a:p>
             <a:pPr algn="l" marL="342900" indent="-342900">
-              <a:spcAft>
-                <a:spcPts val="400"/>
+              <a:lnSpc>
+                <a:spcPct val="100000"/>
+              </a:lnSpc>
+              <a:spcAft>
+                <a:spcPts val="200"/>
               </a:spcAft>
               <a:buFont typeface="Arial"/>
               <a:buChar char="•"/>
             </a:pPr>
             <a:r>
-              <a:rPr sz="1400" b="0"/>
+              <a:rPr sz="1800" b="0"/>
               <a:t>дослідити предметну область пошуку загублених домашніх тварин</a:t>
             </a:r>
           </a:p>
           <a:p>
             <a:pPr algn="l" marL="342900" indent="-342900">
-              <a:spcAft>
-                <a:spcPts val="400"/>
+              <a:lnSpc>
+                <a:spcPct val="100000"/>
+              </a:lnSpc>
+              <a:spcAft>
+                <a:spcPts val="200"/>
               </a:spcAft>
               <a:buFont typeface="Arial"/>
               <a:buChar char="•"/>
             </a:pPr>
             <a:r>
-              <a:rPr sz="1400" b="0"/>
+              <a:rPr sz="1800" b="0"/>
               <a:t>провести аналіз існуючих рішень і підходів</a:t>
             </a:r>
           </a:p>
           <a:p>
             <a:pPr algn="l" marL="342900" indent="-342900">
-              <a:spcAft>
-                <a:spcPts val="400"/>
+              <a:lnSpc>
+                <a:spcPct val="100000"/>
+              </a:lnSpc>
+              <a:spcAft>
+                <a:spcPts val="200"/>
               </a:spcAft>
               <a:buFont typeface="Arial"/>
               <a:buChar char="•"/>
             </a:pPr>
             <a:r>
-              <a:rPr sz="1400" b="0"/>
+              <a:rPr sz="1800" b="0"/>
               <a:t>сформувати функціональні та нефункціональні вимоги до системи</a:t>
             </a:r>
           </a:p>
           <a:p>
             <a:pPr algn="l" marL="342900" indent="-342900">
-              <a:spcAft>
-                <a:spcPts val="400"/>
+              <a:lnSpc>
+                <a:spcPct val="100000"/>
+              </a:lnSpc>
+              <a:spcAft>
+                <a:spcPts val="200"/>
               </a:spcAft>
               <a:buFont typeface="Arial"/>
               <a:buChar char="•"/>
             </a:pPr>
             <a:r>
-              <a:rPr sz="1400" b="0"/>
+              <a:rPr sz="1800" b="0"/>
               <a:t>виконати планування проєкту та оцінювання ризиків</a:t>
             </a:r>
           </a:p>
           <a:p>
             <a:pPr algn="l" marL="342900" indent="-342900">
-              <a:spcAft>
-                <a:spcPts val="400"/>
+              <a:lnSpc>
+                <a:spcPct val="100000"/>
+              </a:lnSpc>
+              <a:spcAft>
+                <a:spcPts val="200"/>
               </a:spcAft>
               <a:buFont typeface="Arial"/>
               <a:buChar char="•"/>
             </a:pPr>
             <a:r>
-              <a:rPr sz="1400" b="0"/>
+              <a:rPr sz="1800" b="0"/>
               <a:t>розробити алгоритм зіставлення та ранжування оголошень-кандидатів</a:t>
             </a:r>
           </a:p>
           <a:p>
             <a:pPr algn="l" marL="342900" indent="-342900">
-              <a:spcAft>
-                <a:spcPts val="400"/>
+              <a:lnSpc>
+                <a:spcPct val="100000"/>
+              </a:lnSpc>
+              <a:spcAft>
+                <a:spcPts val="200"/>
               </a:spcAft>
               <a:buFont typeface="Arial"/>
               <a:buChar char="•"/>
             </a:pPr>
             <a:r>
-              <a:rPr sz="1400" b="0"/>
+              <a:rPr sz="1800" b="0"/>
               <a:t>спроєктувати архітектуру застосунку, структуру бази даних і користувацький інтерфейс</a:t>
             </a:r>
           </a:p>
           <a:p>
             <a:pPr algn="l" marL="342900" indent="-342900">
-              <a:spcAft>
-                <a:spcPts val="400"/>
+              <a:lnSpc>
+                <a:spcPct val="100000"/>
+              </a:lnSpc>
+              <a:spcAft>
+                <a:spcPts val="200"/>
               </a:spcAft>
               <a:buFont typeface="Arial"/>
               <a:buChar char="•"/>
             </a:pPr>
             <a:r>
-              <a:rPr sz="1400" b="0"/>
+              <a:rPr sz="1800" b="0"/>
               <a:t>реалізувати вебзастосунок із використанням сучасних технологій</a:t>
             </a:r>
           </a:p>
           <a:p>
             <a:pPr algn="l" marL="342900" indent="-342900">
-              <a:spcAft>
-                <a:spcPts val="400"/>
+              <a:lnSpc>
+                <a:spcPct val="100000"/>
+              </a:lnSpc>
+              <a:spcAft>
+                <a:spcPts val="200"/>
               </a:spcAft>
               <a:buFont typeface="Arial"/>
               <a:buChar char="•"/>
             </a:pPr>
             <a:r>
-              <a:rPr sz="1400" b="0"/>
+              <a:rPr sz="1800" b="0"/>
               <a:t>провести тестування функціональних і нефункціональних вимог системи</a:t>
+            </a:r>
+          </a:p>
+          <a:p>
+            <a:pPr algn="l" marL="342900" indent="-342900">
+              <a:lnSpc>
+                <a:spcPct val="100000"/>
+              </a:lnSpc>
+              <a:spcAft>
+                <a:spcPts val="200"/>
+              </a:spcAft>
+              <a:buFont typeface="Arial"/>
+              <a:buChar char="•"/>
+            </a:pPr>
+            <a:r>
+              <a:rPr sz="1800" b="0"/>
+              <a:t>провести експериментальне дослідження ефективності розробленого зіставлення на модельному наборі даних</a:t>
             </a:r>
           </a:p>
         </p:txBody>
@@ -10948,8 +11495,8 @@
         </p:nvSpPr>
         <p:spPr>
           <a:xfrm>
-            <a:off x="11280575" y="6201587"/>
-            <a:ext cx="731700" cy="524700"/>
+            <a:off x="11155680" y="137160"/>
+            <a:ext cx="731520" cy="365760"/>
           </a:xfrm>
           <a:prstGeom prst="rect">
             <a:avLst/>
@@ -10998,7 +11545,8 @@
             </a:lvl9pPr>
           </a:lstStyle>
           <a:p>
-            <a:fld id="{C84A8F4A-77E7-40D0-8851-675C4B20C8FA}" type="slidenum">
+            <a:pPr algn="r"/>
+            <a:fld id="{60F07544-08E6-4D88-ADD0-1E7B4519FE0F}" type="slidenum">
               <a:t>1</a:t>
             </a:fld>
           </a:p>
@@ -11038,7 +11586,7 @@
           <a:lstStyle/>
           <a:p>
             <a:r>
-              <a:t>Предмет та об'єкт</a:t>
+              <a:t>Об'єкт та предмет</a:t>
             </a:r>
           </a:p>
         </p:txBody>
@@ -11065,20 +11613,20 @@
               <a:buNone/>
             </a:pPr>
             <a:r>
-              <a:rPr sz="1800" b="1"/>
+              <a:rPr sz="2000" b="1"/>
               <a:t>Об'єкт роботи</a:t>
             </a:r>
           </a:p>
           <a:p>
             <a:pPr algn="l">
               <a:spcAft>
-                <a:spcPts val="1400"/>
+                <a:spcPts val="1200"/>
               </a:spcAft>
               <a:buNone/>
             </a:pPr>
             <a:r>
-              <a:rPr sz="1600" b="0"/>
-              <a:t>Об'єктом роботи є процес пошуку та повернення загублених домашніх тварин на основі зіставлення оголошень про втрату та про знахідку.</a:t>
+              <a:rPr sz="1800" b="0"/>
+              <a:t>Об'єктом роботи є процес автоматизації зіставлення оголошень про загублених і знайдених домашніх тварин засобами вебзастосунку.</a:t>
             </a:r>
           </a:p>
           <a:p>
@@ -11089,7 +11637,7 @@
               <a:buNone/>
             </a:pPr>
             <a:r>
-              <a:rPr sz="1800" b="1"/>
+              <a:rPr sz="2000" b="1"/>
               <a:t>Предмет роботи</a:t>
             </a:r>
           </a:p>
@@ -11101,7 +11649,7 @@
               <a:buNone/>
             </a:pPr>
             <a:r>
-              <a:rPr sz="1600" b="0"/>
+              <a:rPr sz="1800" b="0"/>
               <a:t>Предметом роботи є моделі, алгоритм і програмні засоби вебзастосунку, що забезпечують структуроване подання оголошень і автоматичне формування ранжованого переліку ймовірних збігів із подальшим підтвердженням зв'язку людиною.</a:t>
             </a:r>
           </a:p>
@@ -11119,8 +11667,8 @@
         </p:nvSpPr>
         <p:spPr>
           <a:xfrm>
-            <a:off x="11280575" y="6201587"/>
-            <a:ext cx="731700" cy="524700"/>
+            <a:off x="11155680" y="137160"/>
+            <a:ext cx="731520" cy="365760"/>
           </a:xfrm>
           <a:prstGeom prst="rect">
             <a:avLst/>
@@ -11169,7 +11717,8 @@
             </a:lvl9pPr>
           </a:lstStyle>
           <a:p>
-            <a:fld id="{43EFE717-6B5A-499F-90F8-117E335C6B8D}" type="slidenum">
+            <a:pPr algn="r"/>
+            <a:fld id="{6D4B96BA-C7B5-4919-80AA-2B1AB6C8BD1B}" type="slidenum">
               <a:t>2</a:t>
             </a:fld>
           </a:p>
@@ -11247,7 +11796,7 @@
                     <a:p>
                       <a:pPr algn="ctr"/>
                       <a:r>
-                        <a:rPr b="1" sz="1300"/>
+                        <a:rPr b="1" sz="1800"/>
                         <a:t>Критерій</a:t>
                       </a:r>
                     </a:p>
@@ -11261,7 +11810,7 @@
                     <a:p>
                       <a:pPr algn="ctr"/>
                       <a:r>
-                        <a:rPr b="1" sz="1300"/>
+                        <a:rPr b="1" sz="1800"/>
                         <a:t>PawBoost</a:t>
                       </a:r>
                     </a:p>
@@ -11275,7 +11824,7 @@
                     <a:p>
                       <a:pPr algn="ctr"/>
                       <a:r>
-                        <a:rPr b="1" sz="1300"/>
+                        <a:rPr b="1" sz="1800"/>
                         <a:t>Pet FBI</a:t>
                       </a:r>
                     </a:p>
@@ -11289,7 +11838,7 @@
                     <a:p>
                       <a:pPr algn="ctr"/>
                       <a:r>
-                        <a:rPr b="1" sz="1300"/>
+                        <a:rPr b="1" sz="1800"/>
                         <a:t>Спільноти</a:t>
                       </a:r>
                     </a:p>
@@ -11303,7 +11852,7 @@
                     <a:p>
                       <a:pPr algn="ctr"/>
                       <a:r>
-                        <a:rPr b="1" sz="1300"/>
+                        <a:rPr b="1" sz="1800"/>
                         <a:t>Власна розробка</a:t>
                       </a:r>
                     </a:p>
@@ -11319,7 +11868,7 @@
                     <a:p>
                       <a:pPr algn="l"/>
                       <a:r>
-                        <a:rPr sz="1200"/>
+                        <a:rPr sz="1800"/>
                         <a:t>Структурована модель оголошення</a:t>
                       </a:r>
                     </a:p>
@@ -11333,7 +11882,7 @@
                     <a:p>
                       <a:pPr algn="ctr"/>
                       <a:r>
-                        <a:rPr sz="1200"/>
+                        <a:rPr sz="1800"/>
                         <a:t>+</a:t>
                       </a:r>
                     </a:p>
@@ -11347,7 +11896,7 @@
                     <a:p>
                       <a:pPr algn="ctr"/>
                       <a:r>
-                        <a:rPr sz="1200"/>
+                        <a:rPr sz="1800"/>
                         <a:t>+</a:t>
                       </a:r>
                     </a:p>
@@ -11361,7 +11910,7 @@
                     <a:p>
                       <a:pPr algn="ctr"/>
                       <a:r>
-                        <a:rPr sz="1200"/>
+                        <a:rPr sz="1800"/>
                         <a:t>–</a:t>
                       </a:r>
                     </a:p>
@@ -11375,7 +11924,7 @@
                     <a:p>
                       <a:pPr algn="ctr"/>
                       <a:r>
-                        <a:rPr sz="1200"/>
+                        <a:rPr sz="1800"/>
                         <a:t>+</a:t>
                       </a:r>
                     </a:p>
@@ -11391,8 +11940,8 @@
                     <a:p>
                       <a:pPr algn="l"/>
                       <a:r>
-                        <a:rPr sz="1200"/>
-                        <a:t>Автоматичне зіставлення втрати та знахідки</a:t>
+                        <a:rPr sz="1800"/>
+                        <a:t>Автоматичне зіставлення оголошень</a:t>
                       </a:r>
                     </a:p>
                   </a:txBody>
@@ -11405,7 +11954,7 @@
                     <a:p>
                       <a:pPr algn="ctr"/>
                       <a:r>
-                        <a:rPr sz="1200"/>
+                        <a:rPr sz="1800"/>
                         <a:t>–</a:t>
                       </a:r>
                     </a:p>
@@ -11419,7 +11968,7 @@
                     <a:p>
                       <a:pPr algn="ctr"/>
                       <a:r>
-                        <a:rPr sz="1200"/>
+                        <a:rPr sz="1800"/>
                         <a:t>–</a:t>
                       </a:r>
                     </a:p>
@@ -11433,7 +11982,7 @@
                     <a:p>
                       <a:pPr algn="ctr"/>
                       <a:r>
-                        <a:rPr sz="1200"/>
+                        <a:rPr sz="1800"/>
                         <a:t>–</a:t>
                       </a:r>
                     </a:p>
@@ -11447,7 +11996,7 @@
                     <a:p>
                       <a:pPr algn="ctr"/>
                       <a:r>
-                        <a:rPr sz="1200"/>
+                        <a:rPr sz="1800"/>
                         <a:t>+</a:t>
                       </a:r>
                     </a:p>
@@ -11463,7 +12012,7 @@
                     <a:p>
                       <a:pPr algn="l"/>
                       <a:r>
-                        <a:rPr sz="1200"/>
+                        <a:rPr sz="1800"/>
                         <a:t>Урахування відстані та дати</a:t>
                       </a:r>
                     </a:p>
@@ -11477,7 +12026,7 @@
                     <a:p>
                       <a:pPr algn="ctr"/>
                       <a:r>
-                        <a:rPr sz="1200"/>
+                        <a:rPr sz="1800"/>
                         <a:t>частково</a:t>
                       </a:r>
                     </a:p>
@@ -11491,7 +12040,7 @@
                     <a:p>
                       <a:pPr algn="ctr"/>
                       <a:r>
-                        <a:rPr sz="1200"/>
+                        <a:rPr sz="1800"/>
                         <a:t>частково</a:t>
                       </a:r>
                     </a:p>
@@ -11505,7 +12054,7 @@
                     <a:p>
                       <a:pPr algn="ctr"/>
                       <a:r>
-                        <a:rPr sz="1200"/>
+                        <a:rPr sz="1800"/>
                         <a:t>–</a:t>
                       </a:r>
                     </a:p>
@@ -11519,7 +12068,7 @@
                     <a:p>
                       <a:pPr algn="ctr"/>
                       <a:r>
-                        <a:rPr sz="1200"/>
+                        <a:rPr sz="1800"/>
                         <a:t>+</a:t>
                       </a:r>
                     </a:p>
@@ -11535,7 +12084,7 @@
                     <a:p>
                       <a:pPr algn="l"/>
                       <a:r>
-                        <a:rPr sz="1200"/>
+                        <a:rPr sz="1800"/>
                         <a:t>Ранжування кандидатів</a:t>
                       </a:r>
                     </a:p>
@@ -11549,7 +12098,7 @@
                     <a:p>
                       <a:pPr algn="ctr"/>
                       <a:r>
-                        <a:rPr sz="1200"/>
+                        <a:rPr sz="1800"/>
                         <a:t>–</a:t>
                       </a:r>
                     </a:p>
@@ -11563,7 +12112,7 @@
                     <a:p>
                       <a:pPr algn="ctr"/>
                       <a:r>
-                        <a:rPr sz="1200"/>
+                        <a:rPr sz="1800"/>
                         <a:t>–</a:t>
                       </a:r>
                     </a:p>
@@ -11577,7 +12126,7 @@
                     <a:p>
                       <a:pPr algn="ctr"/>
                       <a:r>
-                        <a:rPr sz="1200"/>
+                        <a:rPr sz="1800"/>
                         <a:t>–</a:t>
                       </a:r>
                     </a:p>
@@ -11591,7 +12140,7 @@
                     <a:p>
                       <a:pPr algn="ctr"/>
                       <a:r>
-                        <a:rPr sz="1200"/>
+                        <a:rPr sz="1800"/>
                         <a:t>+</a:t>
                       </a:r>
                     </a:p>
@@ -11607,7 +12156,7 @@
                     <a:p>
                       <a:pPr algn="l"/>
                       <a:r>
-                        <a:rPr sz="1200"/>
+                        <a:rPr sz="1800"/>
                         <a:t>Підтвердження збігу людиною</a:t>
                       </a:r>
                     </a:p>
@@ -11621,7 +12170,7 @@
                     <a:p>
                       <a:pPr algn="ctr"/>
                       <a:r>
-                        <a:rPr sz="1200"/>
+                        <a:rPr sz="1800"/>
                         <a:t>–</a:t>
                       </a:r>
                     </a:p>
@@ -11635,7 +12184,7 @@
                     <a:p>
                       <a:pPr algn="ctr"/>
                       <a:r>
-                        <a:rPr sz="1200"/>
+                        <a:rPr sz="1800"/>
                         <a:t>–</a:t>
                       </a:r>
                     </a:p>
@@ -11649,7 +12198,7 @@
                     <a:p>
                       <a:pPr algn="ctr"/>
                       <a:r>
-                        <a:rPr sz="1200"/>
+                        <a:rPr sz="1800"/>
                         <a:t>–</a:t>
                       </a:r>
                     </a:p>
@@ -11663,7 +12212,7 @@
                     <a:p>
                       <a:pPr algn="ctr"/>
                       <a:r>
-                        <a:rPr sz="1200"/>
+                        <a:rPr sz="1800"/>
                         <a:t>+</a:t>
                       </a:r>
                     </a:p>
@@ -11679,8 +12228,8 @@
                     <a:p>
                       <a:pPr algn="l"/>
                       <a:r>
-                        <a:rPr sz="1200"/>
-                        <a:t>Приховування контактів до підтвердження</a:t>
+                        <a:rPr sz="1800"/>
+                        <a:t>Контакти приховано до підтвердження</a:t>
                       </a:r>
                     </a:p>
                   </a:txBody>
@@ -11693,7 +12242,7 @@
                     <a:p>
                       <a:pPr algn="ctr"/>
                       <a:r>
-                        <a:rPr sz="1200"/>
+                        <a:rPr sz="1800"/>
                         <a:t>–</a:t>
                       </a:r>
                     </a:p>
@@ -11707,7 +12256,7 @@
                     <a:p>
                       <a:pPr algn="ctr"/>
                       <a:r>
-                        <a:rPr sz="1200"/>
+                        <a:rPr sz="1800"/>
                         <a:t>–</a:t>
                       </a:r>
                     </a:p>
@@ -11721,7 +12270,7 @@
                     <a:p>
                       <a:pPr algn="ctr"/>
                       <a:r>
-                        <a:rPr sz="1200"/>
+                        <a:rPr sz="1800"/>
                         <a:t>–</a:t>
                       </a:r>
                     </a:p>
@@ -11735,7 +12284,7 @@
                     <a:p>
                       <a:pPr algn="ctr"/>
                       <a:r>
-                        <a:rPr sz="1200"/>
+                        <a:rPr sz="1800"/>
                         <a:t>+</a:t>
                       </a:r>
                     </a:p>
@@ -11751,7 +12300,7 @@
                     <a:p>
                       <a:pPr algn="l"/>
                       <a:r>
-                        <a:rPr sz="1200"/>
+                        <a:rPr sz="1800"/>
                         <a:t>Безкоштовність базових функцій</a:t>
                       </a:r>
                     </a:p>
@@ -11765,7 +12314,7 @@
                     <a:p>
                       <a:pPr algn="ctr"/>
                       <a:r>
-                        <a:rPr sz="1200"/>
+                        <a:rPr sz="1800"/>
                         <a:t>частково</a:t>
                       </a:r>
                     </a:p>
@@ -11779,7 +12328,7 @@
                     <a:p>
                       <a:pPr algn="ctr"/>
                       <a:r>
-                        <a:rPr sz="1200"/>
+                        <a:rPr sz="1800"/>
                         <a:t>+</a:t>
                       </a:r>
                     </a:p>
@@ -11793,7 +12342,7 @@
                     <a:p>
                       <a:pPr algn="ctr"/>
                       <a:r>
-                        <a:rPr sz="1200"/>
+                        <a:rPr sz="1800"/>
                         <a:t>+</a:t>
                       </a:r>
                     </a:p>
@@ -11807,7 +12356,7 @@
                     <a:p>
                       <a:pPr algn="ctr"/>
                       <a:r>
-                        <a:rPr sz="1200"/>
+                        <a:rPr sz="1800"/>
                         <a:t>+</a:t>
                       </a:r>
                     </a:p>
@@ -11831,8 +12380,8 @@
         </p:nvSpPr>
         <p:spPr>
           <a:xfrm>
-            <a:off x="11280575" y="6201587"/>
-            <a:ext cx="731700" cy="524700"/>
+            <a:off x="11155680" y="137160"/>
+            <a:ext cx="731520" cy="365760"/>
           </a:xfrm>
           <a:prstGeom prst="rect">
             <a:avLst/>
@@ -11917,7 +12466,8 @@
             </a:lvl9pPr>
           </a:lstStyle>
           <a:p>
-            <a:fld id="{11A09889-9A70-4ED5-9164-814FAE32EF96}" type="slidenum">
+            <a:pPr algn="r"/>
+            <a:fld id="{A3B2A8EA-8243-43BA-8264-2CDA2F454509}" type="slidenum">
               <a:t>3</a:t>
             </a:fld>
           </a:p>
@@ -11999,8 +12549,8 @@
         </p:nvSpPr>
         <p:spPr>
           <a:xfrm>
-            <a:off x="11280575" y="6201587"/>
-            <a:ext cx="731700" cy="524700"/>
+            <a:off x="11155680" y="137160"/>
+            <a:ext cx="731520" cy="365760"/>
           </a:xfrm>
           <a:prstGeom prst="rect">
             <a:avLst/>
@@ -12085,7 +12635,8 @@
             </a:lvl9pPr>
           </a:lstStyle>
           <a:p>
-            <a:fld id="{20E08A7D-D13D-4664-B2F5-6291CA26656B}" type="slidenum">
+            <a:pPr algn="r"/>
+            <a:fld id="{7009612C-6B9C-47D1-B338-5CB3AF8A0B64}" type="slidenum">
               <a:t>4</a:t>
             </a:fld>
           </a:p>
@@ -12167,8 +12718,8 @@
         </p:nvSpPr>
         <p:spPr>
           <a:xfrm>
-            <a:off x="11280575" y="6201587"/>
-            <a:ext cx="731700" cy="524700"/>
+            <a:off x="11155680" y="137160"/>
+            <a:ext cx="731520" cy="365760"/>
           </a:xfrm>
           <a:prstGeom prst="rect">
             <a:avLst/>
@@ -12253,7 +12804,8 @@
             </a:lvl9pPr>
           </a:lstStyle>
           <a:p>
-            <a:fld id="{DCE94AC7-6253-4380-97BD-70CAD47EDF81}" type="slidenum">
+            <a:pPr algn="r"/>
+            <a:fld id="{D682CB13-5E1F-4F7A-BB91-E9874D8D5042}" type="slidenum">
               <a:t>5</a:t>
             </a:fld>
           </a:p>
@@ -12335,8 +12887,8 @@
         </p:nvSpPr>
         <p:spPr>
           <a:xfrm>
-            <a:off x="11280575" y="6201587"/>
-            <a:ext cx="731700" cy="524700"/>
+            <a:off x="11155680" y="137160"/>
+            <a:ext cx="731520" cy="365760"/>
           </a:xfrm>
           <a:prstGeom prst="rect">
             <a:avLst/>
@@ -12421,7 +12973,8 @@
             </a:lvl9pPr>
           </a:lstStyle>
           <a:p>
-            <a:fld id="{22287187-60D5-45CF-BA9B-004E57B8CBC9}" type="slidenum">
+            <a:pPr algn="r"/>
+            <a:fld id="{FCB80E5A-6F73-47AB-A8C1-8D5556DBD06E}" type="slidenum">
               <a:t>6</a:t>
             </a:fld>
           </a:p>
@@ -12483,104 +13036,104 @@
           <a:p>
             <a:pPr algn="l" marL="342900" indent="-342900">
               <a:spcAft>
-                <a:spcPts val="600"/>
+                <a:spcPts val="400"/>
               </a:spcAft>
               <a:buFont typeface="Arial"/>
               <a:buChar char="•"/>
             </a:pPr>
             <a:r>
-              <a:rPr sz="1600" b="0"/>
+              <a:rPr sz="1800" b="0"/>
               <a:t>Платформа та мова: Node.js 22 LTS, TypeScript 5.6</a:t>
             </a:r>
           </a:p>
           <a:p>
             <a:pPr algn="l" marL="342900" indent="-342900">
               <a:spcAft>
-                <a:spcPts val="600"/>
+                <a:spcPts val="400"/>
               </a:spcAft>
               <a:buFont typeface="Arial"/>
               <a:buChar char="•"/>
             </a:pPr>
             <a:r>
-              <a:rPr sz="1600" b="0"/>
+              <a:rPr sz="1800" b="0"/>
               <a:t>Серверний фреймворк: NestJS 11 (модульність, впровадження залежностей)</a:t>
             </a:r>
           </a:p>
           <a:p>
             <a:pPr algn="l" marL="342900" indent="-342900">
               <a:spcAft>
-                <a:spcPts val="600"/>
+                <a:spcPts val="400"/>
               </a:spcAft>
               <a:buFont typeface="Arial"/>
               <a:buChar char="•"/>
             </a:pPr>
             <a:r>
-              <a:rPr sz="1600" b="0"/>
+              <a:rPr sz="1800" b="0"/>
               <a:t>Дані: ORM Drizzle 0.44, PostgreSQL 16</a:t>
             </a:r>
           </a:p>
           <a:p>
             <a:pPr algn="l" marL="342900" indent="-342900">
               <a:spcAft>
-                <a:spcPts val="600"/>
+                <a:spcPts val="400"/>
               </a:spcAft>
               <a:buFont typeface="Arial"/>
               <a:buChar char="•"/>
             </a:pPr>
             <a:r>
-              <a:rPr sz="1600" b="0"/>
+              <a:rPr sz="1800" b="0"/>
               <a:t>Валідація та обробка помилок: Zod, neverthrow</a:t>
             </a:r>
           </a:p>
           <a:p>
             <a:pPr algn="l" marL="342900" indent="-342900">
               <a:spcAft>
-                <a:spcPts val="600"/>
+                <a:spcPts val="400"/>
               </a:spcAft>
               <a:buFont typeface="Arial"/>
               <a:buChar char="•"/>
             </a:pPr>
             <a:r>
-              <a:rPr sz="1600" b="0"/>
+              <a:rPr sz="1800" b="0"/>
               <a:t>Безпека: argon2id, JWT, заголовки безпеки, обмеження джерел запитів</a:t>
             </a:r>
           </a:p>
           <a:p>
             <a:pPr algn="l" marL="342900" indent="-342900">
               <a:spcAft>
-                <a:spcPts val="600"/>
+                <a:spcPts val="400"/>
               </a:spcAft>
               <a:buFont typeface="Arial"/>
               <a:buChar char="•"/>
             </a:pPr>
             <a:r>
-              <a:rPr sz="1600" b="0"/>
+              <a:rPr sz="1800" b="0"/>
               <a:t>Клієнт: React 19, Vite 6, React Router, CSS-модулі</a:t>
             </a:r>
           </a:p>
           <a:p>
             <a:pPr algn="l" marL="342900" indent="-342900">
               <a:spcAft>
-                <a:spcPts val="600"/>
+                <a:spcPts val="400"/>
               </a:spcAft>
               <a:buFont typeface="Arial"/>
               <a:buChar char="•"/>
             </a:pPr>
             <a:r>
-              <a:rPr sz="1600" b="0"/>
+              <a:rPr sz="1800" b="0"/>
               <a:t>Тестування: Vitest, testcontainers (ефемерна БД у контейнері)</a:t>
             </a:r>
           </a:p>
           <a:p>
             <a:pPr algn="l" marL="342900" indent="-342900">
               <a:spcAft>
-                <a:spcPts val="600"/>
+                <a:spcPts val="400"/>
               </a:spcAft>
               <a:buFont typeface="Arial"/>
               <a:buChar char="•"/>
             </a:pPr>
             <a:r>
-              <a:rPr sz="1600" b="0"/>
+              <a:rPr sz="1800" b="0"/>
               <a:t>Інфраструктура: монорепозиторій pnpm + Turborepo, Docker</a:t>
             </a:r>
           </a:p>
@@ -12598,8 +13151,8 @@
         </p:nvSpPr>
         <p:spPr>
           <a:xfrm>
-            <a:off x="11280575" y="6201587"/>
-            <a:ext cx="731700" cy="524700"/>
+            <a:off x="11155680" y="137160"/>
+            <a:ext cx="731520" cy="365760"/>
           </a:xfrm>
           <a:prstGeom prst="rect">
             <a:avLst/>
@@ -12648,7 +13201,8 @@
             </a:lvl9pPr>
           </a:lstStyle>
           <a:p>
-            <a:fld id="{66C07458-2EA0-4D56-AC99-F9E45EE25F18}" type="slidenum">
+            <a:pPr algn="r"/>
+            <a:fld id="{085B805D-BF19-44A8-87B3-9CA7091DC8D2}" type="slidenum">
               <a:t>7</a:t>
             </a:fld>
           </a:p>
@@ -12730,8 +13284,8 @@
         </p:nvSpPr>
         <p:spPr>
           <a:xfrm>
-            <a:off x="11280575" y="6201587"/>
-            <a:ext cx="731700" cy="524700"/>
+            <a:off x="11155680" y="137160"/>
+            <a:ext cx="731520" cy="365760"/>
           </a:xfrm>
           <a:prstGeom prst="rect">
             <a:avLst/>
@@ -12816,7 +13370,8 @@
             </a:lvl9pPr>
           </a:lstStyle>
           <a:p>
-            <a:fld id="{9FA7BA16-A06B-4D2F-BA7D-1AB84A4F70BB}" type="slidenum">
+            <a:pPr algn="r"/>
+            <a:fld id="{E6900060-9E85-4E98-BA72-0C547C125036}" type="slidenum">
               <a:t>8</a:t>
             </a:fld>
           </a:p>

</xml_diff>